<commit_message>
Final polish: one canonical room deck, second-person slide voice, and a dozen small consistency fixes
</commit_message>
<xml_diff>
--- a/enablement/deck/presentation-deck.pptx
+++ b/enablement/deck/presentation-deck.pptx
@@ -777,7 +777,7 @@
           <a:p>
             <a:r>
               <a:rPr lang="en-US" dirty="0"/>
-              <a:t>Close by deleting the local plugin and removing the marketplace so the machine is clean for the next rehearsal, then point the room at the repo. Everything on this slide exists in the published kit today.</a:t>
+              <a:t>Close by uninstalling and reinstalling the plugin on screen, under a minute; distribution is the product, worth showing twice. After the room leaves, uninstall and remove the marketplace so the machine is clean for the next session. Everything on this slide exists in the published kit today.</a:t>
             </a:r>
             <a:endParaRPr lang="en-US" dirty="0"/>
           </a:p>
@@ -865,7 +865,7 @@
           <a:p>
             <a:r>
               <a:rPr lang="en-US" dirty="0"/>
-              <a:t>State the scope out loud before anything else. The cut list is as deliberate as the covered list; the reasons come from 01-design-note.md. If someone wants the cut topics, point them at the docs links on the closing slide.</a:t>
+              <a:t>State the scope out loud before anything else. The cut list is as deliberate as the covered list; the reasons come from 01-design-note.md. If someone wants the cut topics, point them at the docs links at the bottom of the handout.</a:t>
             </a:r>
             <a:endParaRPr lang="en-US" dirty="0"/>
           </a:p>
@@ -6836,7 +6836,7 @@
                 <a:ea typeface="Arial" pitchFamily="34" charset="-122"/>
                 <a:cs typeface="Arial" pitchFamily="34" charset="-120"/>
               </a:rPr>
-              <a:t>try.js gives an instant decision. The 22-check harness guards regressions.</a:t>
+              <a:t>try.js gives an instant decision. The 22-check harness catches regressions.</a:t>
             </a:r>
             <a:endParaRPr lang="en-US" sz="1300" dirty="0"/>
           </a:p>
@@ -7443,7 +7443,7 @@
                 <a:ea typeface="Arial" pitchFamily="34" charset="-122"/>
                 <a:cs typeface="Arial" pitchFamily="34" charset="-120"/>
               </a:rPr>
-              <a:t>Their conventions, applied by their reviewer.</a:t>
+              <a:t>Your conventions, applied by your reviewer.</a:t>
             </a:r>
             <a:endParaRPr lang="en-US" sz="1250" dirty="0"/>
           </a:p>

</xml_diff>